<commit_message>
Fix relationship discovery production timeouts
</commit_message>
<xml_diff>
--- a/Submission/Presentation.pptx
+++ b/Submission/Presentation.pptx
@@ -2,18 +2,18 @@
 <file path=ppt/presentation.xml><?xml version="1.0" encoding="utf-8"?>
 <p:presentation xmlns:p="http://schemas.openxmlformats.org/presentationml/2006/main">
   <p:sldMasterIdLst>
-    <p:sldMasterId xmlns:r="http://schemas.openxmlformats.org/officeDocument/2006/relationships" id="2147483648" r:id="Rb4e4d98aad354c42"/>
+    <p:sldMasterId xmlns:r="http://schemas.openxmlformats.org/officeDocument/2006/relationships" id="2147483648" r:id="R8cac59c0212948ce"/>
   </p:sldMasterIdLst>
   <p:notesMasterIdLst>
-    <p:notesMasterId xmlns:r="http://schemas.openxmlformats.org/officeDocument/2006/relationships" r:id="R6b9652a3c9314d85"/>
+    <p:notesMasterId xmlns:r="http://schemas.openxmlformats.org/officeDocument/2006/relationships" r:id="R2f21b3eaa3174f4b"/>
   </p:notesMasterIdLst>
   <p:sldIdLst>
-    <p:sldId xmlns:r="http://schemas.openxmlformats.org/officeDocument/2006/relationships" id="256" r:id="R8ebbb4b6e24044f1"/>
-    <p:sldId xmlns:r="http://schemas.openxmlformats.org/officeDocument/2006/relationships" id="257" r:id="R9a7d658f5fd24cae"/>
-    <p:sldId xmlns:r="http://schemas.openxmlformats.org/officeDocument/2006/relationships" id="258" r:id="Re8c00ee31b4946a1"/>
-    <p:sldId xmlns:r="http://schemas.openxmlformats.org/officeDocument/2006/relationships" id="259" r:id="R049ea101d80c4fc1"/>
-    <p:sldId xmlns:r="http://schemas.openxmlformats.org/officeDocument/2006/relationships" id="260" r:id="R31f27475a5404ca0"/>
-    <p:sldId xmlns:r="http://schemas.openxmlformats.org/officeDocument/2006/relationships" id="261" r:id="R66a91411077649c9"/>
+    <p:sldId xmlns:r="http://schemas.openxmlformats.org/officeDocument/2006/relationships" id="256" r:id="R825637271ecc4e7f"/>
+    <p:sldId xmlns:r="http://schemas.openxmlformats.org/officeDocument/2006/relationships" id="257" r:id="R111e779445f44003"/>
+    <p:sldId xmlns:r="http://schemas.openxmlformats.org/officeDocument/2006/relationships" id="258" r:id="R0bab2eb6da1847a9"/>
+    <p:sldId xmlns:r="http://schemas.openxmlformats.org/officeDocument/2006/relationships" id="259" r:id="Rf7f33e06004d4a8c"/>
+    <p:sldId xmlns:r="http://schemas.openxmlformats.org/officeDocument/2006/relationships" id="260" r:id="R2386c2677f0d4d6f"/>
+    <p:sldId xmlns:r="http://schemas.openxmlformats.org/officeDocument/2006/relationships" id="261" r:id="R00f6f580531c4dee"/>
   </p:sldIdLst>
   <p:sldSz cx="12192000" cy="6858000"/>
   <p:notesSz cx="6858000" cy="9144000"/>
@@ -473,12 +473,7 @@
           </a:p>
           <a:p xmlns:a="http://schemas.openxmlformats.org/drawingml/2006/main">
             <a:r>
-              <a:t>Internal source: README.md</a:t>
-            </a:r>
-          </a:p>
-          <a:p xmlns:a="http://schemas.openxmlformats.org/drawingml/2006/main">
-            <a:r>
-              <a:t>No external assets or claims.</a:t>
+              <a:t>Internal GradeSense repository content.</a:t>
             </a:r>
           </a:p>
         </p:txBody>
@@ -565,18 +560,7 @@
               <a:buNone/>
             </a:pPr>
             <a:r>
-              <a:t>Internal source: README.md and docs/MODEL_OVERVIEW.md</a:t>
-            </a:r>
-          </a:p>
-          <a:p xmlns:a="http://schemas.openxmlformats.org/drawingml/2006/main">
-            <a:pPr>
-              <a:spcBef>
-                <a:spcPct val="0"/>
-              </a:spcBef>
-              <a:buNone/>
-            </a:pPr>
-            <a:r>
-              <a:t>No external assets or claims.</a:t>
+              <a:t>Honeywell challenge statement supplied by the participant; internal GradeSense repository content.</a:t>
             </a:r>
           </a:p>
         </p:txBody>
@@ -663,18 +647,7 @@
               <a:buNone/>
             </a:pPr>
             <a:r>
-              <a:t>Internal source: docs/SYSTEM_ARCHITECTURE.md, docker-compose.yml, backend/app, frontend/src</a:t>
-            </a:r>
-          </a:p>
-          <a:p xmlns:a="http://schemas.openxmlformats.org/drawingml/2006/main">
-            <a:pPr>
-              <a:spcBef>
-                <a:spcPct val="0"/>
-              </a:spcBef>
-              <a:buNone/>
-            </a:pPr>
-            <a:r>
-              <a:t>No external assets or claims.</a:t>
+              <a:t>Internal GradeSense architecture and deployment documentation.</a:t>
             </a:r>
           </a:p>
         </p:txBody>
@@ -761,18 +734,7 @@
               <a:buNone/>
             </a:pPr>
             <a:r>
-              <a:t>Internal source: frontend/src/pages, frontend/src/components/live, backend/app/services/streaming.py</a:t>
-            </a:r>
-          </a:p>
-          <a:p xmlns:a="http://schemas.openxmlformats.org/drawingml/2006/main">
-            <a:pPr>
-              <a:spcBef>
-                <a:spcPct val="0"/>
-              </a:spcBef>
-              <a:buNone/>
-            </a:pPr>
-            <a:r>
-              <a:t>No external assets or claims.</a:t>
+              <a:t>Internal production captures stored in Submission/deployed_screenshots.</a:t>
             </a:r>
           </a:p>
         </p:txBody>
@@ -859,18 +821,7 @@
               <a:buNone/>
             </a:pPr>
             <a:r>
-              <a:t>Internal source: docs/SYSTEM_ARCHITECTURE.md and backend/app/services</a:t>
-            </a:r>
-          </a:p>
-          <a:p xmlns:a="http://schemas.openxmlformats.org/drawingml/2006/main">
-            <a:pPr>
-              <a:spcBef>
-                <a:spcPct val="0"/>
-              </a:spcBef>
-              <a:buNone/>
-            </a:pPr>
-            <a:r>
-              <a:t>Impact wording is directional; no unvalidated ROI figures are claimed.</a:t>
+              <a:t>Internal GradeSense model and service documentation. Impact language is directional.</a:t>
             </a:r>
           </a:p>
         </p:txBody>
@@ -957,7 +908,7 @@
               <a:buNone/>
             </a:pPr>
             <a:r>
-              <a:t>Internal source: README.md</a:t>
+              <a:t>GitHub Repository: https://github.com/bhavukm007/GradeSense</a:t>
             </a:r>
           </a:p>
           <a:p xmlns:a="http://schemas.openxmlformats.org/drawingml/2006/main">
@@ -968,7 +919,7 @@
               <a:buNone/>
             </a:pPr>
             <a:r>
-              <a:t>Internal source: docs/SYSTEM_ARCHITECTURE.md</a:t>
+              <a:t>Live Deployment: https://gradesense-4weh.onrender.com/</a:t>
             </a:r>
           </a:p>
           <a:p xmlns:a="http://schemas.openxmlformats.org/drawingml/2006/main">
@@ -979,40 +930,7 @@
               <a:buNone/>
             </a:pPr>
             <a:r>
-              <a:t>Internal source: docs/MODEL_OVERVIEW.md</a:t>
-            </a:r>
-          </a:p>
-          <a:p xmlns:a="http://schemas.openxmlformats.org/drawingml/2006/main">
-            <a:pPr>
-              <a:spcBef>
-                <a:spcPct val="0"/>
-              </a:spcBef>
-              <a:buNone/>
-            </a:pPr>
-            <a:r>
-              <a:t>Internal source: docs/API_REFERENCE.md</a:t>
-            </a:r>
-          </a:p>
-          <a:p xmlns:a="http://schemas.openxmlformats.org/drawingml/2006/main">
-            <a:pPr>
-              <a:spcBef>
-                <a:spcPct val="0"/>
-              </a:spcBef>
-              <a:buNone/>
-            </a:pPr>
-            <a:r>
-              <a:t>Internal source: docs/DEPLOYMENT.md</a:t>
-            </a:r>
-          </a:p>
-          <a:p xmlns:a="http://schemas.openxmlformats.org/drawingml/2006/main">
-            <a:pPr>
-              <a:spcBef>
-                <a:spcPct val="0"/>
-              </a:spcBef>
-              <a:buNone/>
-            </a:pPr>
-            <a:r>
-              <a:t>No external assets or claims.</a:t>
+              <a:t>Demo Video: https://drive.google.com/file/d/1rCr3CzuCit0O029VzyxIhHoR1lv9E93E/view?usp=sharing</a:t>
             </a:r>
           </a:p>
         </p:txBody>
@@ -4241,17 +4159,17 @@
   </p:cSld>
   <p:clrMap bg1="lt1" tx1="dk1" bg2="lt2" tx2="dk2" accent1="accent1" accent2="accent2" accent3="accent3" accent4="accent4" accent5="accent5" accent6="accent6" hlink="hlink" folHlink="folHlink"/>
   <p:sldLayoutIdLst>
-    <p:sldLayoutId xmlns:r="http://schemas.openxmlformats.org/officeDocument/2006/relationships" id="2147483649" r:id="R603d39083e93497e"/>
-    <p:sldLayoutId xmlns:r="http://schemas.openxmlformats.org/officeDocument/2006/relationships" id="2147483650" r:id="Ra548e1afa2844bea"/>
-    <p:sldLayoutId xmlns:r="http://schemas.openxmlformats.org/officeDocument/2006/relationships" id="2147483651" r:id="R25f8c44506e649ec"/>
-    <p:sldLayoutId xmlns:r="http://schemas.openxmlformats.org/officeDocument/2006/relationships" id="2147483652" r:id="R502b7ee3987d4dc1"/>
-    <p:sldLayoutId xmlns:r="http://schemas.openxmlformats.org/officeDocument/2006/relationships" id="2147483653" r:id="Ra86f4deea7e242b4"/>
-    <p:sldLayoutId xmlns:r="http://schemas.openxmlformats.org/officeDocument/2006/relationships" id="2147483654" r:id="R32b0a28e48544792"/>
-    <p:sldLayoutId xmlns:r="http://schemas.openxmlformats.org/officeDocument/2006/relationships" id="2147483655" r:id="Rec0c399c17ed4850"/>
-    <p:sldLayoutId xmlns:r="http://schemas.openxmlformats.org/officeDocument/2006/relationships" id="2147483656" r:id="R4e8981584a8d4515"/>
-    <p:sldLayoutId xmlns:r="http://schemas.openxmlformats.org/officeDocument/2006/relationships" id="2147483657" r:id="R15dc9af4ac724b86"/>
-    <p:sldLayoutId xmlns:r="http://schemas.openxmlformats.org/officeDocument/2006/relationships" id="2147483658" r:id="R29e2cca842044bfe"/>
-    <p:sldLayoutId xmlns:r="http://schemas.openxmlformats.org/officeDocument/2006/relationships" id="2147483659" r:id="Rc1895939e1994fb8"/>
+    <p:sldLayoutId xmlns:r="http://schemas.openxmlformats.org/officeDocument/2006/relationships" id="2147483649" r:id="R15f7dc41aedb4f92"/>
+    <p:sldLayoutId xmlns:r="http://schemas.openxmlformats.org/officeDocument/2006/relationships" id="2147483650" r:id="R27781c44e0b349d6"/>
+    <p:sldLayoutId xmlns:r="http://schemas.openxmlformats.org/officeDocument/2006/relationships" id="2147483651" r:id="Rc76150fe06214890"/>
+    <p:sldLayoutId xmlns:r="http://schemas.openxmlformats.org/officeDocument/2006/relationships" id="2147483652" r:id="R9e78d54b86b04bf4"/>
+    <p:sldLayoutId xmlns:r="http://schemas.openxmlformats.org/officeDocument/2006/relationships" id="2147483653" r:id="Rffb1222e9b7b4566"/>
+    <p:sldLayoutId xmlns:r="http://schemas.openxmlformats.org/officeDocument/2006/relationships" id="2147483654" r:id="R37543d6fa86f4bb6"/>
+    <p:sldLayoutId xmlns:r="http://schemas.openxmlformats.org/officeDocument/2006/relationships" id="2147483655" r:id="R019afe1812b94bfe"/>
+    <p:sldLayoutId xmlns:r="http://schemas.openxmlformats.org/officeDocument/2006/relationships" id="2147483656" r:id="R2de7502262644f61"/>
+    <p:sldLayoutId xmlns:r="http://schemas.openxmlformats.org/officeDocument/2006/relationships" id="2147483657" r:id="Raf126c91011f4fd5"/>
+    <p:sldLayoutId xmlns:r="http://schemas.openxmlformats.org/officeDocument/2006/relationships" id="2147483658" r:id="Rdce415d2694f405f"/>
+    <p:sldLayoutId xmlns:r="http://schemas.openxmlformats.org/officeDocument/2006/relationships" id="2147483659" r:id="R07a44436c2264ef8"/>
   </p:sldLayoutIdLst>
   <p:hf hdr="0" dt="0"/>
   <p:txStyles>
@@ -5238,7 +5156,7 @@
         <p:spPr>
           <a:xfrm xmlns:a="http://schemas.openxmlformats.org/drawingml/2006/main">
             <a:off x="397274" y="1203454"/>
-            <a:ext cx="5924550" cy="4754880"/>
+            <a:ext cx="5924550" cy="6217920"/>
           </a:xfrm>
           <a:prstGeom xmlns:a="http://schemas.openxmlformats.org/drawingml/2006/main" prst="rect">
             <a:avLst/>
@@ -5286,7 +5204,7 @@
                 <a:ea typeface="Arial"/>
                 <a:cs typeface="Arial"/>
               </a:rPr>
-              <a:t>Early prediction of off-spec risk</a:t>
+              <a:t>Problem: predict off-spec basis-weight risk before limits are exceeded</a:t>
             </a:r>
           </a:p>
           <a:p xmlns:a="http://schemas.openxmlformats.org/drawingml/2006/main">
@@ -5303,7 +5221,7 @@
                 <a:ea typeface="Arial"/>
                 <a:cs typeface="Arial"/>
               </a:rPr>
-              <a:t>Safe, explainable operator guidance</a:t>
+              <a:t>Team: GradeSense | Bhavuk Mahajan</a:t>
             </a:r>
           </a:p>
           <a:p xmlns:a="http://schemas.openxmlformats.org/drawingml/2006/main">
@@ -5320,7 +5238,7 @@
                 <a:ea typeface="Arial"/>
                 <a:cs typeface="Arial"/>
               </a:rPr>
-              <a:t>Honeywell Hackathon | GradeSense Team</a:t>
+              <a:t>Honeywell Hackathon Final Submission</a:t>
             </a:r>
           </a:p>
         </p:txBody>
@@ -5385,7 +5303,7 @@
               <a:buNone/>
             </a:pPr>
             <a:r>
-              <a:t>PROBLEM STATEMENT</a:t>
+              <a:t>PROBLEM</a:t>
             </a:r>
           </a:p>
         </p:txBody>
@@ -5604,7 +5522,7 @@
                 <a:ea typeface="Times New Roman"/>
                 <a:cs typeface="Times New Roman"/>
               </a:rPr>
-              <a:t>TECHNICAL ARCHITECTURE</a:t>
+              <a:t>TECHNICAL APPROACH</a:t>
             </a:r>
           </a:p>
         </p:txBody>
@@ -5666,7 +5584,7 @@
                 <a:ea typeface="Arial"/>
                 <a:cs typeface="Arial"/>
               </a:rPr>
-              <a:t>Snapshot ML + direct-horizon forecasting -&gt; explainability + constraint-aware recommendation engine</a:t>
+              <a:t>Snapshot ML + direct-horizon forecasting -&gt; explainability -&gt; safe recommendation ranking</a:t>
             </a:r>
           </a:p>
           <a:p xmlns:a="http://schemas.openxmlformats.org/drawingml/2006/main">
@@ -5680,7 +5598,7 @@
                 <a:ea typeface="Arial"/>
                 <a:cs typeface="Arial"/>
               </a:rPr>
-              <a:t>SQLAlchemy + PostgreSQL/SQLite persist predictions, alerts, decisions, outcomes, audit, and model registry</a:t>
+              <a:t>SQLAlchemy + PostgreSQL/SQLite persist predictions, alerts, decisions, outcomes, audit, and models</a:t>
             </a:r>
           </a:p>
           <a:p xmlns:a="http://schemas.openxmlformats.org/drawingml/2006/main">
@@ -5694,7 +5612,7 @@
                 <a:ea typeface="Arial"/>
                 <a:cs typeface="Arial"/>
               </a:rPr>
-              <a:t>Docker, Nginx, Alembic, health checks, and read-only model artifacts support deployment</a:t>
+              <a:t>Dockerized frontend/backend deployment on Render with health checks and environment configuration</a:t>
             </a:r>
           </a:p>
         </p:txBody>
@@ -5823,7 +5741,7 @@
                 <a:ea typeface="Times New Roman"/>
                 <a:cs typeface="Times New Roman"/>
               </a:rPr>
-              <a:t>DASHBOARD + AI PIPELINE</a:t>
+              <a:t>SOLUTION DEMONSTRATION</a:t>
             </a:r>
           </a:p>
         </p:txBody>
@@ -5845,7 +5763,7 @@
         <p:spPr>
           <a:xfrm xmlns:a="http://schemas.openxmlformats.org/drawingml/2006/main">
             <a:off x="609600" y="2533653"/>
-            <a:ext cx="9385300" cy="3078480"/>
+            <a:ext cx="9385300" cy="1384995"/>
           </a:xfrm>
           <a:prstGeom xmlns:a="http://schemas.openxmlformats.org/drawingml/2006/main" prst="rect">
             <a:avLst/>
@@ -5885,7 +5803,7 @@
                 <a:ea typeface="Arial"/>
                 <a:cs typeface="Arial"/>
               </a:rPr>
-              <a:t>Dashboard: live trends, off-spec risk, alerts, recommendations, analytics, history, and system health</a:t>
+              <a:t/>
             </a:r>
           </a:p>
           <a:p xmlns:a="http://schemas.openxmlformats.org/drawingml/2006/main">
@@ -5913,38 +5831,7 @@
                 <a:ea typeface="Arial"/>
                 <a:cs typeface="Arial"/>
               </a:rPr>
-              <a:t>AI pipeline: validate -&gt; engineer features -&gt; predict/forecast -&gt; explain -&gt; constrain -&gt; simulate -&gt; rank</a:t>
-            </a:r>
-          </a:p>
-          <a:p xmlns:a="http://schemas.openxmlformats.org/drawingml/2006/main">
-            <a:pPr marL="342900" marR="0" lvl="0" indent="-342900" defTabSz="457200">
-              <a:lnSpc>
-                <a:spcPct val="100000"/>
-              </a:lnSpc>
-              <a:spcBef>
-                <a:spcPct val="0"/>
-              </a:spcBef>
-              <a:spcAft>
-                <a:spcPct val="0"/>
-              </a:spcAft>
-              <a:buClrTx/>
-              <a:buSzTx/>
-              <a:buFont typeface="Arial"/>
-              <a:buChar char="•"/>
-            </a:pPr>
-            <a:r>
-              <a:rPr sz="2800" b="0" i="0" u="none" cap="none">
-                <a:ln>
-                  <a:noFill/>
-                </a:ln>
-                <a:solidFill>
-                  <a:prstClr val="black"/>
-                </a:solidFill>
-                <a:latin typeface="Arial"/>
-                <a:ea typeface="Arial"/>
-                <a:cs typeface="Arial"/>
-              </a:rPr>
-              <a:t>WebSocket events keep sensor updates, predictions, drift, alerts, and recommendations synchronized</a:t>
+              <a:t/>
             </a:r>
           </a:p>
         </p:txBody>
@@ -6060,6 +5947,81 @@
           </a:p>
         </p:txBody>
       </p:sp>
+      <p:pic>
+        <p:nvPicPr>
+          <p:cNvPr id="17418" name=""/>
+          <p:cNvPicPr>
+            <a:picLocks xmlns:a="http://schemas.openxmlformats.org/drawingml/2006/main" noChangeAspect="1"/>
+          </p:cNvPicPr>
+          <p:nvPr/>
+        </p:nvPicPr>
+        <p:blipFill>
+          <a:blip xmlns:r="http://schemas.openxmlformats.org/officeDocument/2006/relationships" xmlns:a="http://schemas.openxmlformats.org/drawingml/2006/main" r:embed="R98cd31347ad244c8"/>
+          <a:srcRect xmlns:a="http://schemas.openxmlformats.org/drawingml/2006/main" l="14474" t="0" r="14474" b="0"/>
+          <a:stretch xmlns:a="http://schemas.openxmlformats.org/drawingml/2006/main">
+            <a:fillRect l="0" t="0" r="0" b="0"/>
+          </a:stretch>
+        </p:blipFill>
+        <p:spPr>
+          <a:xfrm xmlns:a="http://schemas.openxmlformats.org/drawingml/2006/main">
+            <a:off x="590550" y="2095500"/>
+            <a:ext cx="3429000" cy="2714625"/>
+          </a:xfrm>
+          <a:prstGeom xmlns:a="http://schemas.openxmlformats.org/drawingml/2006/main" prst="rect">
+            <a:avLst/>
+          </a:prstGeom>
+        </p:spPr>
+      </p:pic>
+      <p:pic>
+        <p:nvPicPr>
+          <p:cNvPr id="17419" name=""/>
+          <p:cNvPicPr>
+            <a:picLocks xmlns:a="http://schemas.openxmlformats.org/drawingml/2006/main" noChangeAspect="1"/>
+          </p:cNvPicPr>
+          <p:nvPr/>
+        </p:nvPicPr>
+        <p:blipFill>
+          <a:blip xmlns:r="http://schemas.openxmlformats.org/officeDocument/2006/relationships" xmlns:a="http://schemas.openxmlformats.org/drawingml/2006/main" r:embed="Ra6d99e9a89424464"/>
+          <a:srcRect xmlns:a="http://schemas.openxmlformats.org/drawingml/2006/main" l="7596" t="0" r="7596" b="0"/>
+          <a:stretch xmlns:a="http://schemas.openxmlformats.org/drawingml/2006/main">
+            <a:fillRect l="0" t="0" r="0" b="0"/>
+          </a:stretch>
+        </p:blipFill>
+        <p:spPr>
+          <a:xfrm xmlns:a="http://schemas.openxmlformats.org/drawingml/2006/main">
+            <a:off x="4381500" y="2095500"/>
+            <a:ext cx="3429000" cy="2714625"/>
+          </a:xfrm>
+          <a:prstGeom xmlns:a="http://schemas.openxmlformats.org/drawingml/2006/main" prst="rect">
+            <a:avLst/>
+          </a:prstGeom>
+        </p:spPr>
+      </p:pic>
+      <p:pic>
+        <p:nvPicPr>
+          <p:cNvPr id="17420" name=""/>
+          <p:cNvPicPr>
+            <a:picLocks xmlns:a="http://schemas.openxmlformats.org/drawingml/2006/main" noChangeAspect="1"/>
+          </p:cNvPicPr>
+          <p:nvPr/>
+        </p:nvPicPr>
+        <p:blipFill>
+          <a:blip xmlns:r="http://schemas.openxmlformats.org/officeDocument/2006/relationships" xmlns:a="http://schemas.openxmlformats.org/drawingml/2006/main" r:embed="Rd9566c1486834bb3"/>
+          <a:srcRect xmlns:a="http://schemas.openxmlformats.org/drawingml/2006/main" l="0" t="4747" r="0" b="4747"/>
+          <a:stretch xmlns:a="http://schemas.openxmlformats.org/drawingml/2006/main">
+            <a:fillRect l="0" t="0" r="0" b="0"/>
+          </a:stretch>
+        </p:blipFill>
+        <p:spPr>
+          <a:xfrm xmlns:a="http://schemas.openxmlformats.org/drawingml/2006/main">
+            <a:off x="8172450" y="2095500"/>
+            <a:ext cx="3429000" cy="2714625"/>
+          </a:xfrm>
+          <a:prstGeom xmlns:a="http://schemas.openxmlformats.org/drawingml/2006/main" prst="rect">
+            <a:avLst/>
+          </a:prstGeom>
+        </p:spPr>
+      </p:pic>
     </p:spTree>
     <p:extLst>
       <p:ext uri="{BB962C8B-B14F-4D97-AF65-F5344CB8AC3E}">
@@ -6112,7 +6074,7 @@
                 <a:ea typeface="Times New Roman"/>
                 <a:cs typeface="Times New Roman"/>
               </a:rPr>
-              <a:t>BUSINESS IMPACT + INNOVATION</a:t>
+              <a:t>INNOVATION + RESULTS</a:t>
             </a:r>
           </a:p>
         </p:txBody>
@@ -6174,7 +6136,7 @@
                 <a:ea typeface="Arial"/>
                 <a:cs typeface="Arial"/>
               </a:rPr>
-              <a:t>Earlier risk visibility supports intervention before quality drift becomes avoidable waste.</a:t>
+              <a:t>Early basis-weight risk visibility supports intervention before avoidable off-spec production.</a:t>
             </a:r>
           </a:p>
           <a:p xmlns:a="http://schemas.openxmlformats.org/drawingml/2006/main">
@@ -6191,7 +6153,7 @@
                 <a:ea typeface="Arial"/>
                 <a:cs typeface="Arial"/>
               </a:rPr>
-              <a:t>Direct-horizon forecasting projects the transition without recursive error accumulation.</a:t>
+              <a:t>Direct-horizon forecasting reduces recursive error accumulation during grade transitions.</a:t>
             </a:r>
           </a:p>
           <a:p xmlns:a="http://schemas.openxmlformats.org/drawingml/2006/main">
@@ -6211,7 +6173,7 @@
                 <a:ea typeface="Arial"/>
                 <a:cs typeface="Arial"/>
               </a:rPr>
-              <a:t>Recommendations are constraint-checked and simulated against a persisted baseline.</a:t>
+              <a:t>Explainable, constraint-checked recommendations keep operators in the decision loop.</a:t>
             </a:r>
           </a:p>
           <a:p xmlns:a="http://schemas.openxmlformats.org/drawingml/2006/main">
@@ -6228,7 +6190,7 @@
                 <a:ea typeface="Arial"/>
                 <a:cs typeface="Arial"/>
               </a:rPr>
-              <a:t>Explanations, operator decisions, and observed outcomes create an auditable learning loop.</a:t>
+              <a:t>Predictions, decisions, and outcomes form an auditable learning loop, deployed live on Render.</a:t>
             </a:r>
           </a:p>
         </p:txBody>
@@ -6396,7 +6358,7 @@
                 <a:ea typeface="Times New Roman"/>
                 <a:cs typeface="Times New Roman"/>
               </a:rPr>
-              <a:t>RESEARCH AND REFERENCES</a:t>
+              <a:t>REFERENCES</a:t>
             </a:r>
           </a:p>
         </p:txBody>
@@ -6418,7 +6380,7 @@
         <p:spPr>
           <a:xfrm xmlns:a="http://schemas.openxmlformats.org/drawingml/2006/main">
             <a:off x="609600" y="2795263"/>
-            <a:ext cx="9385300" cy="2225040"/>
+            <a:ext cx="9385300" cy="3505200"/>
           </a:xfrm>
           <a:prstGeom xmlns:a="http://schemas.openxmlformats.org/drawingml/2006/main" prst="rect">
             <a:avLst/>
@@ -6458,7 +6420,147 @@
                 <a:ea typeface="Arial"/>
                 <a:cs typeface="Arial"/>
               </a:rPr>
-              <a:t>GradeSense repository: README.md | docs/SYSTEM_ARCHITECTURE.md | docs/MODEL_OVERVIEW.md | docs/API_REFERENCE.md | docs/DEPLOYMENT.md | backend/app | frontend/src</a:t>
+              <a:t>GitHub Repository</a:t>
+            </a:r>
+          </a:p>
+          <a:p xmlns:a="http://schemas.openxmlformats.org/drawingml/2006/main">
+            <a:pPr marL="342900" marR="0" lvl="0" indent="-342900" defTabSz="457200">
+              <a:lnSpc>
+                <a:spcPct val="100000"/>
+              </a:lnSpc>
+              <a:spcBef>
+                <a:spcPct val="0"/>
+              </a:spcBef>
+              <a:spcAft>
+                <a:spcPct val="0"/>
+              </a:spcAft>
+              <a:buClrTx/>
+              <a:buSzTx/>
+              <a:buFont typeface="Arial"/>
+              <a:buChar char="•"/>
+            </a:pPr>
+            <a:r>
+              <a:rPr sz="2800">
+                <a:solidFill>
+                  <a:prstClr val="black"/>
+                </a:solidFill>
+                <a:latin typeface="Arial"/>
+                <a:ea typeface="Arial"/>
+                <a:cs typeface="Arial"/>
+              </a:rPr>
+              <a:t>https://github.com/bhavukm007/GradeSense</a:t>
+            </a:r>
+          </a:p>
+          <a:p xmlns:a="http://schemas.openxmlformats.org/drawingml/2006/main">
+            <a:pPr marL="342900" marR="0" lvl="0" indent="-342900" defTabSz="457200">
+              <a:lnSpc>
+                <a:spcPct val="100000"/>
+              </a:lnSpc>
+              <a:spcBef>
+                <a:spcPct val="0"/>
+              </a:spcBef>
+              <a:spcAft>
+                <a:spcPct val="0"/>
+              </a:spcAft>
+              <a:buClrTx/>
+              <a:buSzTx/>
+              <a:buFont typeface="Arial"/>
+              <a:buChar char="•"/>
+            </a:pPr>
+            <a:r>
+              <a:rPr sz="2800">
+                <a:solidFill>
+                  <a:prstClr val="black"/>
+                </a:solidFill>
+                <a:latin typeface="Arial"/>
+                <a:ea typeface="Arial"/>
+                <a:cs typeface="Arial"/>
+              </a:rPr>
+              <a:t>Live Deployment</a:t>
+            </a:r>
+          </a:p>
+          <a:p xmlns:a="http://schemas.openxmlformats.org/drawingml/2006/main">
+            <a:pPr marL="342900" marR="0" lvl="0" indent="-342900" defTabSz="457200">
+              <a:lnSpc>
+                <a:spcPct val="100000"/>
+              </a:lnSpc>
+              <a:spcBef>
+                <a:spcPct val="0"/>
+              </a:spcBef>
+              <a:spcAft>
+                <a:spcPct val="0"/>
+              </a:spcAft>
+              <a:buClrTx/>
+              <a:buSzTx/>
+              <a:buFont typeface="Arial"/>
+              <a:buChar char="•"/>
+            </a:pPr>
+            <a:r>
+              <a:rPr sz="2800">
+                <a:solidFill>
+                  <a:prstClr val="black"/>
+                </a:solidFill>
+                <a:latin typeface="Arial"/>
+                <a:ea typeface="Arial"/>
+                <a:cs typeface="Arial"/>
+              </a:rPr>
+              <a:t>https://gradesense-4weh.onrender.com/</a:t>
+            </a:r>
+          </a:p>
+          <a:p xmlns:a="http://schemas.openxmlformats.org/drawingml/2006/main">
+            <a:pPr marL="342900" marR="0" lvl="0" indent="-342900" defTabSz="457200">
+              <a:lnSpc>
+                <a:spcPct val="100000"/>
+              </a:lnSpc>
+              <a:spcBef>
+                <a:spcPct val="0"/>
+              </a:spcBef>
+              <a:spcAft>
+                <a:spcPct val="0"/>
+              </a:spcAft>
+              <a:buClrTx/>
+              <a:buSzTx/>
+              <a:buFont typeface="Arial"/>
+              <a:buChar char="•"/>
+            </a:pPr>
+            <a:r>
+              <a:rPr sz="2800">
+                <a:solidFill>
+                  <a:prstClr val="black"/>
+                </a:solidFill>
+                <a:latin typeface="Arial"/>
+                <a:ea typeface="Arial"/>
+                <a:cs typeface="Arial"/>
+              </a:rPr>
+              <a:t>Demo Video</a:t>
+            </a:r>
+          </a:p>
+          <a:p xmlns:a="http://schemas.openxmlformats.org/drawingml/2006/main">
+            <a:pPr marL="342900" marR="0" lvl="0" indent="-342900" defTabSz="457200">
+              <a:lnSpc>
+                <a:spcPct val="100000"/>
+              </a:lnSpc>
+              <a:spcBef>
+                <a:spcPct val="0"/>
+              </a:spcBef>
+              <a:spcAft>
+                <a:spcPct val="0"/>
+              </a:spcAft>
+              <a:buClrTx/>
+              <a:buSzTx/>
+              <a:buFont typeface="Arial"/>
+              <a:buChar char="•"/>
+            </a:pPr>
+            <a:r>
+              <a:rPr sz="2800">
+                <a:solidFill>
+                  <a:prstClr val="black"/>
+                </a:solidFill>
+                <a:latin typeface="Arial"/>
+                <a:ea typeface="Arial"/>
+                <a:cs typeface="Arial"/>
+              </a:rPr>
+              <a:t>https://drive.google.com/file/d/1rCr3CzuCit0O029VzyxIhHoR1lv9E93E/view?usp=sharing</a:t>
             </a:r>
           </a:p>
         </p:txBody>

</xml_diff>